<commit_message>
Audit & hilangkan AI-tell dari slide Metrik SAFE AI
Hapus em-dash (judul slide, body, referensi), ganti aforisme penutup
dengan kalimat faktual, dan ubah judul triad retoris.

Co-Authored-By: Claude Opus 4.8 (1M context) <noreply@anthropic.com>
</commit_message>
<xml_diff>
--- a/safe/metrics/SAFE-AI-Metrics.pptx
+++ b/safe/metrics/SAFE-AI-Metrics.pptx
@@ -4060,7 +4060,7 @@
                 </a:solidFill>
                 <a:latin typeface="Calibri"/>
               </a:rPr>
-              <a:t>SSL — Fairness. Metrik: 8 notasi fairness; metode minimax adversarial.</a:t>
+              <a:t>Paradigma SSL, dimensi Fairness. Metrik: 8 notasi fairness; metode minimax adversarial.</a:t>
             </a:r>
           </a:p>
         </p:txBody>
@@ -4272,7 +4272,7 @@
                 </a:solidFill>
                 <a:latin typeface="Calibri"/>
               </a:rPr>
-              <a:t>LLM — Secure/Fair/Accountable. 8 perspektif; AdvGLUE++ ASR hingga 89,2%.</a:t>
+              <a:t>LLM, dimensi Secure/Fair/Accountable. 8 perspektif; AdvGLUE++ ASR hingga 89,2%.</a:t>
             </a:r>
           </a:p>
         </p:txBody>
@@ -4484,7 +4484,7 @@
                 </a:solidFill>
                 <a:latin typeface="Calibri"/>
               </a:rPr>
-              <a:t>LLM — multi-metrik. 7 metrik × 16 skenario; robustness &amp; fairness worst-case.</a:t>
+              <a:t>LLM, evaluasi multi-metrik. 7 metrik × 16 skenario; robustness &amp; fairness worst-case.</a:t>
             </a:r>
           </a:p>
         </p:txBody>
@@ -5842,7 +5842,7 @@
                 </a:solidFill>
                 <a:latin typeface="Calibri"/>
               </a:rPr>
-              <a:t>Tiga Paper, Tiga Sudut</a:t>
+              <a:t>Tiga Paper yang Dipakai</a:t>
             </a:r>
           </a:p>
         </p:txBody>
@@ -7119,7 +7119,7 @@
                 </a:solidFill>
                 <a:latin typeface="Calibri"/>
               </a:rPr>
-              <a:t>SoFCLR — Fairness Tanpa Label</a:t>
+              <a:t>SoFCLR: Fairness Tanpa Label</a:t>
             </a:r>
           </a:p>
         </p:txBody>
@@ -7821,7 +7821,7 @@
                 </a:solidFill>
                 <a:latin typeface="Calibri"/>
               </a:rPr>
-              <a:t> — menyiasati global contrastive loss yang mahal.</a:t>
+              <a:t>, menyiasati global contrastive loss yang mahal.</a:t>
             </a:r>
           </a:p>
         </p:txBody>
@@ -8504,7 +8504,7 @@
                 </a:solidFill>
                 <a:latin typeface="Calibri"/>
               </a:rPr>
-              <a:t>Penulis menegaskan SSL tidak inheren adil — pra-pelatihan tetap dapat menyandi bias bila tidak diberi sinyal fairness eksplisit.</a:t>
+              <a:t>Penulis menegaskan SSL tidak inheren adil; pra-pelatihan tetap dapat menyandi bias bila tidak diberi sinyal fairness eksplisit.</a:t>
             </a:r>
           </a:p>
         </p:txBody>
@@ -8696,7 +8696,7 @@
                 </a:solidFill>
                 <a:latin typeface="Calibri"/>
               </a:rPr>
-              <a:t>DecodingTrust — 8 Perspektif</a:t>
+              <a:t>DecodingTrust: 8 Perspektif</a:t>
             </a:r>
           </a:p>
         </p:txBody>
@@ -9831,7 +9831,7 @@
                 </a:solidFill>
                 <a:latin typeface="Calibri"/>
               </a:rPr>
-              <a:t>Robustness diuji dengan benchmark AdvGLUE / AdvGLUE++ (serangan TextFooler, SemAttack, BERT-ATTACK) — Attack Success Rate mencapai 89,2% pada GPT-4 (kasus transfer terbaik). </a:t>
+              <a:t>Robustness diuji dengan benchmark AdvGLUE / AdvGLUE++ (serangan TextFooler, SemAttack, BERT-ATTACK). Attack Success Rate mencapai 89,2% pada GPT-4 (kasus transfer terbaik). </a:t>
             </a:r>
           </a:p>
           <a:p>
@@ -10042,7 +10042,7 @@
                 </a:solidFill>
                 <a:latin typeface="Calibri"/>
               </a:rPr>
-              <a:t>HELM — Evaluasi Holistik</a:t>
+              <a:t>HELM: Evaluasi Holistik</a:t>
             </a:r>
           </a:p>
         </p:txBody>
@@ -13262,7 +13262,7 @@
                 </a:solidFill>
                 <a:latin typeface="Calibri"/>
               </a:rPr>
-              <a:t>AutoML tidak punya satu pun paper metrik SAFE yang lolos verifikasi — ini gap riset nyata, bukan sekadar belum sempat dicari.</a:t>
+              <a:t>AutoML tidak punya satu pun paper metrik SAFE yang lolos verifikasi. Ini gap riset nyata, bukan sekadar belum sempat dicari.</a:t>
             </a:r>
           </a:p>
         </p:txBody>
@@ -13987,7 +13987,7 @@
                 </a:solidFill>
                 <a:latin typeface="Calibri"/>
               </a:rPr>
-              <a:t>Mengukur SAFE adalah syarat untuk memperbaikinya: yang tak terukur tak bisa diperbaiki.</a:t>
+              <a:t>Ketiga paper menyediakan metrik yang bisa langsung dipakai untuk menguji SAFE pada model nyata.</a:t>
             </a:r>
           </a:p>
         </p:txBody>

</xml_diff>

<commit_message>
Tambah speaker notes (bahasa awam) + ganti judul jadi Poin Penutup
Notes siap-baca untuk 16 slide tertanam di PPTX + file speaker-notes.md
terpisah. Gaya bahasa sehari-hari dengan analogi (mobil, rapor, kucing-
tikus) agar audiens awam paham SAFE AI. Judul slide 15: Poin Penutup.

Co-Authored-By: Claude Opus 4.8 (1M context) <noreply@anthropic.com>
</commit_message>
<xml_diff>
--- a/safe/metrics/SAFE-AI-Metrics.pptx
+++ b/safe/metrics/SAFE-AI-Metrics.pptx
@@ -120,6 +120,1476 @@
     </a:lvl9pPr>
   </p:defaultTextStyle>
 </p:presentation>
+</file>
+
+<file path=ppt/notesMasters/notesMaster1.xml><?xml version="1.0" encoding="utf-8"?>
+<p:notesMaster xmlns:a="http://schemas.openxmlformats.org/drawingml/2006/main" xmlns:p="http://schemas.openxmlformats.org/presentationml/2006/main" xmlns:r="http://schemas.openxmlformats.org/officeDocument/2006/relationships">
+  <p:cSld>
+    <p:bg>
+      <p:bgRef idx="1001">
+        <a:schemeClr val="bg1"/>
+      </p:bgRef>
+    </p:bg>
+    <p:spTree>
+      <p:nvGrpSpPr>
+        <p:cNvPr id="1" name=""/>
+        <p:cNvGrpSpPr/>
+        <p:nvPr/>
+      </p:nvGrpSpPr>
+      <p:grpSpPr>
+        <a:xfrm>
+          <a:off x="0" y="0"/>
+          <a:ext cx="0" cy="0"/>
+          <a:chOff x="0" y="0"/>
+          <a:chExt cx="0" cy="0"/>
+        </a:xfrm>
+      </p:grpSpPr>
+      <p:sp>
+        <p:nvSpPr>
+          <p:cNvPr id="2" name="Header Placeholder 1"/>
+          <p:cNvSpPr>
+            <a:spLocks noGrp="1"/>
+          </p:cNvSpPr>
+          <p:nvPr>
+            <p:ph type="hdr" sz="quarter"/>
+          </p:nvPr>
+        </p:nvSpPr>
+        <p:spPr>
+          <a:xfrm>
+            <a:off x="0" y="0"/>
+            <a:ext cx="2971800" cy="457200"/>
+          </a:xfrm>
+          <a:prstGeom prst="rect">
+            <a:avLst/>
+          </a:prstGeom>
+        </p:spPr>
+        <p:txBody>
+          <a:bodyPr vert="horz" lIns="91440" tIns="45720" rIns="91440" bIns="45720" rtlCol="0"/>
+          <a:lstStyle>
+            <a:lvl1pPr algn="l">
+              <a:defRPr sz="1200"/>
+            </a:lvl1pPr>
+          </a:lstStyle>
+          <a:p>
+            <a:endParaRPr lang="en-US"/>
+          </a:p>
+        </p:txBody>
+      </p:sp>
+      <p:sp>
+        <p:nvSpPr>
+          <p:cNvPr id="3" name="Date Placeholder 2"/>
+          <p:cNvSpPr>
+            <a:spLocks noGrp="1"/>
+          </p:cNvSpPr>
+          <p:nvPr>
+            <p:ph type="dt" idx="1"/>
+          </p:nvPr>
+        </p:nvSpPr>
+        <p:spPr>
+          <a:xfrm>
+            <a:off x="3884613" y="0"/>
+            <a:ext cx="2971800" cy="457200"/>
+          </a:xfrm>
+          <a:prstGeom prst="rect">
+            <a:avLst/>
+          </a:prstGeom>
+        </p:spPr>
+        <p:txBody>
+          <a:bodyPr vert="horz" lIns="91440" tIns="45720" rIns="91440" bIns="45720" rtlCol="0"/>
+          <a:lstStyle>
+            <a:lvl1pPr algn="r">
+              <a:defRPr sz="1200"/>
+            </a:lvl1pPr>
+          </a:lstStyle>
+          <a:p>
+            <a:fld id="{0F89C1C7-3DCD-1040-A9CF-14679D8B5DDD}" type="datetimeFigureOut">
+              <a:rPr lang="en-US" smtClean="0"/>
+              <a:t>10/17/16</a:t>
+            </a:fld>
+            <a:endParaRPr lang="en-US"/>
+          </a:p>
+        </p:txBody>
+      </p:sp>
+      <p:sp>
+        <p:nvSpPr>
+          <p:cNvPr id="4" name="Slide Image Placeholder 3"/>
+          <p:cNvSpPr>
+            <a:spLocks noGrp="1" noRot="1" noChangeAspect="1"/>
+          </p:cNvSpPr>
+          <p:nvPr>
+            <p:ph type="sldImg" idx="2"/>
+          </p:nvPr>
+        </p:nvSpPr>
+        <p:spPr>
+          <a:xfrm>
+            <a:off x="1143000" y="685800"/>
+            <a:ext cx="4572000" cy="3429000"/>
+          </a:xfrm>
+          <a:prstGeom prst="rect">
+            <a:avLst/>
+          </a:prstGeom>
+          <a:noFill/>
+          <a:ln w="12700">
+            <a:solidFill>
+              <a:prstClr val="black"/>
+            </a:solidFill>
+          </a:ln>
+        </p:spPr>
+        <p:txBody>
+          <a:bodyPr vert="horz" lIns="91440" tIns="45720" rIns="91440" bIns="45720" rtlCol="0" anchor="ctr"/>
+          <a:lstStyle/>
+          <a:p>
+            <a:endParaRPr lang="en-US"/>
+          </a:p>
+        </p:txBody>
+      </p:sp>
+      <p:sp>
+        <p:nvSpPr>
+          <p:cNvPr id="5" name="Notes Placeholder 4"/>
+          <p:cNvSpPr>
+            <a:spLocks noGrp="1"/>
+          </p:cNvSpPr>
+          <p:nvPr>
+            <p:ph type="body" sz="quarter" idx="3"/>
+          </p:nvPr>
+        </p:nvSpPr>
+        <p:spPr>
+          <a:xfrm>
+            <a:off x="685800" y="4343400"/>
+            <a:ext cx="5486400" cy="4114800"/>
+          </a:xfrm>
+          <a:prstGeom prst="rect">
+            <a:avLst/>
+          </a:prstGeom>
+        </p:spPr>
+        <p:txBody>
+          <a:bodyPr vert="horz" lIns="91440" tIns="45720" rIns="91440" bIns="45720" rtlCol="0"/>
+          <a:lstStyle/>
+          <a:p>
+            <a:pPr lvl="0"/>
+            <a:r>
+              <a:rPr lang="en-US" smtClean="0"/>
+              <a:t>Click to edit Master text styles</a:t>
+            </a:r>
+          </a:p>
+          <a:p>
+            <a:pPr lvl="1"/>
+            <a:r>
+              <a:rPr lang="en-US" smtClean="0"/>
+              <a:t>Second level</a:t>
+            </a:r>
+          </a:p>
+          <a:p>
+            <a:pPr lvl="2"/>
+            <a:r>
+              <a:rPr lang="en-US" smtClean="0"/>
+              <a:t>Third level</a:t>
+            </a:r>
+          </a:p>
+          <a:p>
+            <a:pPr lvl="3"/>
+            <a:r>
+              <a:rPr lang="en-US" smtClean="0"/>
+              <a:t>Fourth level</a:t>
+            </a:r>
+          </a:p>
+          <a:p>
+            <a:pPr lvl="4"/>
+            <a:r>
+              <a:rPr lang="en-US" smtClean="0"/>
+              <a:t>Fifth level</a:t>
+            </a:r>
+            <a:endParaRPr lang="en-US"/>
+          </a:p>
+        </p:txBody>
+      </p:sp>
+      <p:sp>
+        <p:nvSpPr>
+          <p:cNvPr id="6" name="Footer Placeholder 5"/>
+          <p:cNvSpPr>
+            <a:spLocks noGrp="1"/>
+          </p:cNvSpPr>
+          <p:nvPr>
+            <p:ph type="ftr" sz="quarter" idx="4"/>
+          </p:nvPr>
+        </p:nvSpPr>
+        <p:spPr>
+          <a:xfrm>
+            <a:off x="0" y="8685213"/>
+            <a:ext cx="2971800" cy="457200"/>
+          </a:xfrm>
+          <a:prstGeom prst="rect">
+            <a:avLst/>
+          </a:prstGeom>
+        </p:spPr>
+        <p:txBody>
+          <a:bodyPr vert="horz" lIns="91440" tIns="45720" rIns="91440" bIns="45720" rtlCol="0" anchor="b"/>
+          <a:lstStyle>
+            <a:lvl1pPr algn="l">
+              <a:defRPr sz="1200"/>
+            </a:lvl1pPr>
+          </a:lstStyle>
+          <a:p>
+            <a:endParaRPr lang="en-US"/>
+          </a:p>
+        </p:txBody>
+      </p:sp>
+      <p:sp>
+        <p:nvSpPr>
+          <p:cNvPr id="7" name="Slide Number Placeholder 6"/>
+          <p:cNvSpPr>
+            <a:spLocks noGrp="1"/>
+          </p:cNvSpPr>
+          <p:nvPr>
+            <p:ph type="sldNum" sz="quarter" idx="5"/>
+          </p:nvPr>
+        </p:nvSpPr>
+        <p:spPr>
+          <a:xfrm>
+            <a:off x="3884613" y="8685213"/>
+            <a:ext cx="2971800" cy="457200"/>
+          </a:xfrm>
+          <a:prstGeom prst="rect">
+            <a:avLst/>
+          </a:prstGeom>
+        </p:spPr>
+        <p:txBody>
+          <a:bodyPr vert="horz" lIns="91440" tIns="45720" rIns="91440" bIns="45720" rtlCol="0" anchor="b"/>
+          <a:lstStyle>
+            <a:lvl1pPr algn="r">
+              <a:defRPr sz="1200"/>
+            </a:lvl1pPr>
+          </a:lstStyle>
+          <a:p>
+            <a:fld id="{BB5E49A5-4136-284D-997B-48E1D791AD67}" type="slidenum">
+              <a:rPr lang="en-US" smtClean="0"/>
+              <a:t>‹#›</a:t>
+            </a:fld>
+            <a:endParaRPr lang="en-US"/>
+          </a:p>
+        </p:txBody>
+      </p:sp>
+    </p:spTree>
+    <p:extLst>
+      <p:ext uri="{BB962C8B-B14F-4D97-AF65-F5344CB8AC3E}">
+        <p14:creationId xmlns:p14="http://schemas.microsoft.com/office/powerpoint/2010/main" val="2623252185"/>
+      </p:ext>
+    </p:extLst>
+  </p:cSld>
+  <p:clrMap bg1="lt1" tx1="dk1" bg2="lt2" tx2="dk2" accent1="accent1" accent2="accent2" accent3="accent3" accent4="accent4" accent5="accent5" accent6="accent6" hlink="hlink" folHlink="folHlink"/>
+  <p:notesStyle>
+    <a:lvl1pPr marL="0" algn="l" defTabSz="457200" rtl="0" eaLnBrk="1" latinLnBrk="0" hangingPunct="1">
+      <a:defRPr sz="1200" kern="1200">
+        <a:solidFill>
+          <a:schemeClr val="tx1"/>
+        </a:solidFill>
+        <a:latin typeface="+mn-lt"/>
+        <a:ea typeface="+mn-ea"/>
+        <a:cs typeface="+mn-cs"/>
+      </a:defRPr>
+    </a:lvl1pPr>
+    <a:lvl2pPr marL="457200" algn="l" defTabSz="457200" rtl="0" eaLnBrk="1" latinLnBrk="0" hangingPunct="1">
+      <a:defRPr sz="1200" kern="1200">
+        <a:solidFill>
+          <a:schemeClr val="tx1"/>
+        </a:solidFill>
+        <a:latin typeface="+mn-lt"/>
+        <a:ea typeface="+mn-ea"/>
+        <a:cs typeface="+mn-cs"/>
+      </a:defRPr>
+    </a:lvl2pPr>
+    <a:lvl3pPr marL="914400" algn="l" defTabSz="457200" rtl="0" eaLnBrk="1" latinLnBrk="0" hangingPunct="1">
+      <a:defRPr sz="1200" kern="1200">
+        <a:solidFill>
+          <a:schemeClr val="tx1"/>
+        </a:solidFill>
+        <a:latin typeface="+mn-lt"/>
+        <a:ea typeface="+mn-ea"/>
+        <a:cs typeface="+mn-cs"/>
+      </a:defRPr>
+    </a:lvl3pPr>
+    <a:lvl4pPr marL="1371600" algn="l" defTabSz="457200" rtl="0" eaLnBrk="1" latinLnBrk="0" hangingPunct="1">
+      <a:defRPr sz="1200" kern="1200">
+        <a:solidFill>
+          <a:schemeClr val="tx1"/>
+        </a:solidFill>
+        <a:latin typeface="+mn-lt"/>
+        <a:ea typeface="+mn-ea"/>
+        <a:cs typeface="+mn-cs"/>
+      </a:defRPr>
+    </a:lvl4pPr>
+    <a:lvl5pPr marL="1828800" algn="l" defTabSz="457200" rtl="0" eaLnBrk="1" latinLnBrk="0" hangingPunct="1">
+      <a:defRPr sz="1200" kern="1200">
+        <a:solidFill>
+          <a:schemeClr val="tx1"/>
+        </a:solidFill>
+        <a:latin typeface="+mn-lt"/>
+        <a:ea typeface="+mn-ea"/>
+        <a:cs typeface="+mn-cs"/>
+      </a:defRPr>
+    </a:lvl5pPr>
+    <a:lvl6pPr marL="2286000" algn="l" defTabSz="457200" rtl="0" eaLnBrk="1" latinLnBrk="0" hangingPunct="1">
+      <a:defRPr sz="1200" kern="1200">
+        <a:solidFill>
+          <a:schemeClr val="tx1"/>
+        </a:solidFill>
+        <a:latin typeface="+mn-lt"/>
+        <a:ea typeface="+mn-ea"/>
+        <a:cs typeface="+mn-cs"/>
+      </a:defRPr>
+    </a:lvl6pPr>
+    <a:lvl7pPr marL="2743200" algn="l" defTabSz="457200" rtl="0" eaLnBrk="1" latinLnBrk="0" hangingPunct="1">
+      <a:defRPr sz="1200" kern="1200">
+        <a:solidFill>
+          <a:schemeClr val="tx1"/>
+        </a:solidFill>
+        <a:latin typeface="+mn-lt"/>
+        <a:ea typeface="+mn-ea"/>
+        <a:cs typeface="+mn-cs"/>
+      </a:defRPr>
+    </a:lvl7pPr>
+    <a:lvl8pPr marL="3200400" algn="l" defTabSz="457200" rtl="0" eaLnBrk="1" latinLnBrk="0" hangingPunct="1">
+      <a:defRPr sz="1200" kern="1200">
+        <a:solidFill>
+          <a:schemeClr val="tx1"/>
+        </a:solidFill>
+        <a:latin typeface="+mn-lt"/>
+        <a:ea typeface="+mn-ea"/>
+        <a:cs typeface="+mn-cs"/>
+      </a:defRPr>
+    </a:lvl8pPr>
+    <a:lvl9pPr marL="3657600" algn="l" defTabSz="457200" rtl="0" eaLnBrk="1" latinLnBrk="0" hangingPunct="1">
+      <a:defRPr sz="1200" kern="1200">
+        <a:solidFill>
+          <a:schemeClr val="tx1"/>
+        </a:solidFill>
+        <a:latin typeface="+mn-lt"/>
+        <a:ea typeface="+mn-ea"/>
+        <a:cs typeface="+mn-cs"/>
+      </a:defRPr>
+    </a:lvl9pPr>
+  </p:notesStyle>
+</p:notesMaster>
+</file>
+
+<file path=ppt/notesSlides/notesSlide1.xml><?xml version="1.0" encoding="utf-8"?>
+<p:notes xmlns:a="http://schemas.openxmlformats.org/drawingml/2006/main" xmlns:p="http://schemas.openxmlformats.org/presentationml/2006/main" xmlns:r="http://schemas.openxmlformats.org/officeDocument/2006/relationships">
+  <p:cSld>
+    <p:spTree>
+      <p:nvGrpSpPr>
+        <p:cNvPr id="1" name=""/>
+        <p:cNvGrpSpPr/>
+        <p:nvPr/>
+      </p:nvGrpSpPr>
+      <p:grpSpPr>
+        <a:xfrm>
+          <a:off x="0" y="0"/>
+          <a:ext cx="0" cy="0"/>
+          <a:chOff x="0" y="0"/>
+          <a:chExt cx="0" cy="0"/>
+        </a:xfrm>
+      </p:grpSpPr>
+      <p:sp>
+        <p:nvSpPr>
+          <p:cNvPr id="2" name="Slide Image Placeholder 1"/>
+          <p:cNvSpPr>
+            <a:spLocks noGrp="1"/>
+          </p:cNvSpPr>
+          <p:nvPr>
+            <p:ph type="sldImg" idx="2"/>
+          </p:nvPr>
+        </p:nvSpPr>
+        <p:spPr/>
+      </p:sp>
+      <p:sp>
+        <p:nvSpPr>
+          <p:cNvPr id="3" name="Notes Placeholder 2"/>
+          <p:cNvSpPr>
+            <a:spLocks noGrp="1"/>
+          </p:cNvSpPr>
+          <p:nvPr>
+            <p:ph type="body" idx="3" sz="quarter"/>
+          </p:nvPr>
+        </p:nvSpPr>
+        <p:spPr/>
+        <p:txBody>
+          <a:bodyPr/>
+          <a:lstStyle/>
+          <a:p>
+            <a:r>
+              <a:t>Selamat pagi, Bapak Ibu. Topik besar kelompok kami adalah SAFE AI. Empat huruf S-A-F-E adalah singkatan dari empat sifat yang harus dimiliki AI yang baik: Secure atau aman, Accountable atau bisa dipertanggungjawabkan, Fair atau adil, dan Explainable atau bisa dijelaskan. Bagian saya menjawab satu pertanyaan praktis: bagaimana cara kita MENGUKUR apakah sebuah AI benar-benar punya empat sifat itu, bukan sekadar diklaim. Saya jelaskan lewat tiga paper penelitian terkini. Tenang saja, saya pakai bahasa sehari-hari, jadi yang belum familiar dengan AI tetap bisa mengikuti.</a:t>
+            </a:r>
+          </a:p>
+        </p:txBody>
+      </p:sp>
+      <p:sp>
+        <p:nvSpPr>
+          <p:cNvPr id="4" name="Slide Number Placeholder 3"/>
+          <p:cNvSpPr>
+            <a:spLocks noGrp="1"/>
+          </p:cNvSpPr>
+          <p:nvPr>
+            <p:ph type="sldNum" idx="5" sz="quarter"/>
+          </p:nvPr>
+        </p:nvSpPr>
+        <p:spPr/>
+      </p:sp>
+    </p:spTree>
+  </p:cSld>
+  <p:clrMapOvr>
+    <a:masterClrMapping/>
+  </p:clrMapOvr>
+</p:notes>
+</file>
+
+<file path=ppt/notesSlides/notesSlide10.xml><?xml version="1.0" encoding="utf-8"?>
+<p:notes xmlns:a="http://schemas.openxmlformats.org/drawingml/2006/main" xmlns:p="http://schemas.openxmlformats.org/presentationml/2006/main" xmlns:r="http://schemas.openxmlformats.org/officeDocument/2006/relationships">
+  <p:cSld>
+    <p:spTree>
+      <p:nvGrpSpPr>
+        <p:cNvPr id="1" name=""/>
+        <p:cNvGrpSpPr/>
+        <p:nvPr/>
+      </p:nvGrpSpPr>
+      <p:grpSpPr>
+        <a:xfrm>
+          <a:off x="0" y="0"/>
+          <a:ext cx="0" cy="0"/>
+          <a:chOff x="0" y="0"/>
+          <a:chExt cx="0" cy="0"/>
+        </a:xfrm>
+      </p:grpSpPr>
+      <p:sp>
+        <p:nvSpPr>
+          <p:cNvPr id="2" name="Slide Image Placeholder 1"/>
+          <p:cNvSpPr>
+            <a:spLocks noGrp="1"/>
+          </p:cNvSpPr>
+          <p:nvPr>
+            <p:ph type="sldImg" idx="2"/>
+          </p:nvPr>
+        </p:nvSpPr>
+        <p:spPr/>
+      </p:sp>
+      <p:sp>
+        <p:nvSpPr>
+          <p:cNvPr id="3" name="Notes Placeholder 2"/>
+          <p:cNvSpPr>
+            <a:spLocks noGrp="1"/>
+          </p:cNvSpPr>
+          <p:nvPr>
+            <p:ph type="body" idx="3" sz="quarter"/>
+          </p:nvPr>
+        </p:nvSpPr>
+        <p:spPr/>
+        <p:txBody>
+          <a:bodyPr/>
+          <a:lstStyle/>
+          <a:p>
+            <a:r>
+              <a:t>Masuk paper kedua, DecodingTrust. Paper ini menguji model sekelas ChatGPT, yaitu GPT 3.5 dan GPT 4. Ibarat medical check-up menyeluruh, mereka memeriksa delapan aspek. Saya kelompokkan ke tiga warna sesuai SAFE. Merah untuk aman: ketahanan terhadap serangan, terhadap data aneh, dan kebocoran data pribadi. Hijau untuk adil: apakah model punya stereotip atau berat sebelah. Biru untuk tanggung jawab: soal etika dan ucapan kasar. Di kotak bawah ada temuan kuncinya, yang saya bahas lebih jelas di slide berikut.</a:t>
+            </a:r>
+          </a:p>
+        </p:txBody>
+      </p:sp>
+      <p:sp>
+        <p:nvSpPr>
+          <p:cNvPr id="4" name="Slide Number Placeholder 3"/>
+          <p:cNvSpPr>
+            <a:spLocks noGrp="1"/>
+          </p:cNvSpPr>
+          <p:nvPr>
+            <p:ph type="sldNum" idx="5" sz="quarter"/>
+          </p:nvPr>
+        </p:nvSpPr>
+        <p:spPr/>
+      </p:sp>
+    </p:spTree>
+  </p:cSld>
+  <p:clrMapOvr>
+    <a:masterClrMapping/>
+  </p:clrMapOvr>
+</p:notes>
+</file>
+
+<file path=ppt/notesSlides/notesSlide11.xml><?xml version="1.0" encoding="utf-8"?>
+<p:notes xmlns:a="http://schemas.openxmlformats.org/drawingml/2006/main" xmlns:p="http://schemas.openxmlformats.org/presentationml/2006/main" xmlns:r="http://schemas.openxmlformats.org/officeDocument/2006/relationships">
+  <p:cSld>
+    <p:spTree>
+      <p:nvGrpSpPr>
+        <p:cNvPr id="1" name=""/>
+        <p:cNvGrpSpPr/>
+        <p:nvPr/>
+      </p:nvGrpSpPr>
+      <p:grpSpPr>
+        <a:xfrm>
+          <a:off x="0" y="0"/>
+          <a:ext cx="0" cy="0"/>
+          <a:chOff x="0" y="0"/>
+          <a:chExt cx="0" cy="0"/>
+        </a:xfrm>
+      </p:grpSpPr>
+      <p:sp>
+        <p:nvSpPr>
+          <p:cNvPr id="2" name="Slide Image Placeholder 1"/>
+          <p:cNvSpPr>
+            <a:spLocks noGrp="1"/>
+          </p:cNvSpPr>
+          <p:nvPr>
+            <p:ph type="sldImg" idx="2"/>
+          </p:nvPr>
+        </p:nvSpPr>
+        <p:spPr/>
+      </p:sp>
+      <p:sp>
+        <p:nvSpPr>
+          <p:cNvPr id="3" name="Notes Placeholder 2"/>
+          <p:cNvSpPr>
+            <a:spLocks noGrp="1"/>
+          </p:cNvSpPr>
+          <p:nvPr>
+            <p:ph type="body" idx="3" sz="quarter"/>
+          </p:nvPr>
+        </p:nvSpPr>
+        <p:spPr/>
+        <p:txBody>
+          <a:bodyPr/>
+          <a:lstStyle/>
+          <a:p>
+            <a:r>
+              <a:t>Rangkuman paper kedua. Metode: menguji GPT dengan soal-soal jebakan, termasuk serangan yang sengaja dibuat. Temuan pentingnya mengejutkan: GPT 4 lebih pintar dan lebih sopan dalam kondisi normal, tapi justru lebih mudah dikadali kalau ada yang sengaja menjebak. Istilahnya jailbreak, yaitu mengakali AI agar melanggar aturannya. Hasil: dengan trik tertentu, serangan berhasil sampai delapan puluh sembilan persen pada GPT 4. Soal keadilan ada tarik-ulur: makin akurat justru bisa makin tidak adil pada data yang timpang. Rencana lanjutan: menguji dengan percakapan yang lebih panjang dan berliku.</a:t>
+            </a:r>
+          </a:p>
+        </p:txBody>
+      </p:sp>
+      <p:sp>
+        <p:nvSpPr>
+          <p:cNvPr id="4" name="Slide Number Placeholder 3"/>
+          <p:cNvSpPr>
+            <a:spLocks noGrp="1"/>
+          </p:cNvSpPr>
+          <p:nvPr>
+            <p:ph type="sldNum" idx="5" sz="quarter"/>
+          </p:nvPr>
+        </p:nvSpPr>
+        <p:spPr/>
+      </p:sp>
+    </p:spTree>
+  </p:cSld>
+  <p:clrMapOvr>
+    <a:masterClrMapping/>
+  </p:clrMapOvr>
+</p:notes>
+</file>
+
+<file path=ppt/notesSlides/notesSlide12.xml><?xml version="1.0" encoding="utf-8"?>
+<p:notes xmlns:a="http://schemas.openxmlformats.org/drawingml/2006/main" xmlns:p="http://schemas.openxmlformats.org/presentationml/2006/main" xmlns:r="http://schemas.openxmlformats.org/officeDocument/2006/relationships">
+  <p:cSld>
+    <p:spTree>
+      <p:nvGrpSpPr>
+        <p:cNvPr id="1" name=""/>
+        <p:cNvGrpSpPr/>
+        <p:nvPr/>
+      </p:nvGrpSpPr>
+      <p:grpSpPr>
+        <a:xfrm>
+          <a:off x="0" y="0"/>
+          <a:ext cx="0" cy="0"/>
+          <a:chOff x="0" y="0"/>
+          <a:chExt cx="0" cy="0"/>
+        </a:xfrm>
+      </p:grpSpPr>
+      <p:sp>
+        <p:nvSpPr>
+          <p:cNvPr id="2" name="Slide Image Placeholder 1"/>
+          <p:cNvSpPr>
+            <a:spLocks noGrp="1"/>
+          </p:cNvSpPr>
+          <p:nvPr>
+            <p:ph type="sldImg" idx="2"/>
+          </p:nvPr>
+        </p:nvSpPr>
+        <p:spPr/>
+      </p:sp>
+      <p:sp>
+        <p:nvSpPr>
+          <p:cNvPr id="3" name="Notes Placeholder 2"/>
+          <p:cNvSpPr>
+            <a:spLocks noGrp="1"/>
+          </p:cNvSpPr>
+          <p:nvPr>
+            <p:ph type="body" idx="3" sz="quarter"/>
+          </p:nvPr>
+        </p:nvSpPr>
+        <p:spPr/>
+        <p:txBody>
+          <a:bodyPr/>
+          <a:lstStyle/>
+          <a:p>
+            <a:r>
+              <a:t>Paper ketiga, HELM. Kalau dua paper tadi mendalami satu hal, HELM ini melebar. Bayangkan situs pembanding produk, atau rapor sekolah dengan banyak mata pelajaran. HELM memberi nilai tujuh ukuran sekaligus, mulai dari ketepatan, ketahanan, sampai keadilan, untuk tiga puluh model AI berbeda. Tujuannya supaya semua model bisa dibandingkan secara adil dengan ukuran yang sama. Di bawah, saya tunjukkan dua contoh: cara mereka mengukur ketahanan, dan cara mengukur keadilan, misalnya dengan mengubah dialek bahasa.</a:t>
+            </a:r>
+          </a:p>
+        </p:txBody>
+      </p:sp>
+      <p:sp>
+        <p:nvSpPr>
+          <p:cNvPr id="4" name="Slide Number Placeholder 3"/>
+          <p:cNvSpPr>
+            <a:spLocks noGrp="1"/>
+          </p:cNvSpPr>
+          <p:nvPr>
+            <p:ph type="sldNum" idx="5" sz="quarter"/>
+          </p:nvPr>
+        </p:nvSpPr>
+        <p:spPr/>
+      </p:sp>
+    </p:spTree>
+  </p:cSld>
+  <p:clrMapOvr>
+    <a:masterClrMapping/>
+  </p:clrMapOvr>
+</p:notes>
+</file>
+
+<file path=ppt/notesSlides/notesSlide13.xml><?xml version="1.0" encoding="utf-8"?>
+<p:notes xmlns:a="http://schemas.openxmlformats.org/drawingml/2006/main" xmlns:p="http://schemas.openxmlformats.org/presentationml/2006/main" xmlns:r="http://schemas.openxmlformats.org/officeDocument/2006/relationships">
+  <p:cSld>
+    <p:spTree>
+      <p:nvGrpSpPr>
+        <p:cNvPr id="1" name=""/>
+        <p:cNvGrpSpPr/>
+        <p:nvPr/>
+      </p:nvGrpSpPr>
+      <p:grpSpPr>
+        <a:xfrm>
+          <a:off x="0" y="0"/>
+          <a:ext cx="0" cy="0"/>
+          <a:chOff x="0" y="0"/>
+          <a:chExt cx="0" cy="0"/>
+        </a:xfrm>
+      </p:grpSpPr>
+      <p:sp>
+        <p:nvSpPr>
+          <p:cNvPr id="2" name="Slide Image Placeholder 1"/>
+          <p:cNvSpPr>
+            <a:spLocks noGrp="1"/>
+          </p:cNvSpPr>
+          <p:nvPr>
+            <p:ph type="sldImg" idx="2"/>
+          </p:nvPr>
+        </p:nvSpPr>
+        <p:spPr/>
+      </p:sp>
+      <p:sp>
+        <p:nvSpPr>
+          <p:cNvPr id="3" name="Notes Placeholder 2"/>
+          <p:cNvSpPr>
+            <a:spLocks noGrp="1"/>
+          </p:cNvSpPr>
+          <p:nvPr>
+            <p:ph type="body" idx="3" sz="quarter"/>
+          </p:nvPr>
+        </p:nvSpPr>
+        <p:spPr/>
+        <p:txBody>
+          <a:bodyPr/>
+          <a:lstStyle/>
+          <a:p>
+            <a:r>
+              <a:t>Rangkuman paper ketiga. Metode: rapor tujuh ukuran untuk enam belas jenis tugas. Kontribusi: mereka membuat perbandingan jadi transparan, dan jujur menunjukkan apa yang belum terukur. Hasil menarik: model yang lebih kecil tapi dilatih dengan baik bisa mengalahkan model raksasa, jadi besar belum tentu lebih pintar. Mereka juga menemukan AI bekerja lebih buruk untuk dialek kelompok minoritas, ini bukti ketidakadilan yang nyata. Rencana lanjutan: menambah cakupan bahasa selain Inggris dan tugas yang lebih interaktif.</a:t>
+            </a:r>
+          </a:p>
+        </p:txBody>
+      </p:sp>
+      <p:sp>
+        <p:nvSpPr>
+          <p:cNvPr id="4" name="Slide Number Placeholder 3"/>
+          <p:cNvSpPr>
+            <a:spLocks noGrp="1"/>
+          </p:cNvSpPr>
+          <p:nvPr>
+            <p:ph type="sldNum" idx="5" sz="quarter"/>
+          </p:nvPr>
+        </p:nvSpPr>
+        <p:spPr/>
+      </p:sp>
+    </p:spTree>
+  </p:cSld>
+  <p:clrMapOvr>
+    <a:masterClrMapping/>
+  </p:clrMapOvr>
+</p:notes>
+</file>
+
+<file path=ppt/notesSlides/notesSlide14.xml><?xml version="1.0" encoding="utf-8"?>
+<p:notes xmlns:a="http://schemas.openxmlformats.org/drawingml/2006/main" xmlns:p="http://schemas.openxmlformats.org/presentationml/2006/main" xmlns:r="http://schemas.openxmlformats.org/officeDocument/2006/relationships">
+  <p:cSld>
+    <p:spTree>
+      <p:nvGrpSpPr>
+        <p:cNvPr id="1" name=""/>
+        <p:cNvGrpSpPr/>
+        <p:nvPr/>
+      </p:nvGrpSpPr>
+      <p:grpSpPr>
+        <a:xfrm>
+          <a:off x="0" y="0"/>
+          <a:ext cx="0" cy="0"/>
+          <a:chOff x="0" y="0"/>
+          <a:chExt cx="0" cy="0"/>
+        </a:xfrm>
+      </p:grpSpPr>
+      <p:sp>
+        <p:nvSpPr>
+          <p:cNvPr id="2" name="Slide Image Placeholder 1"/>
+          <p:cNvSpPr>
+            <a:spLocks noGrp="1"/>
+          </p:cNvSpPr>
+          <p:nvPr>
+            <p:ph type="sldImg" idx="2"/>
+          </p:nvPr>
+        </p:nvSpPr>
+        <p:spPr/>
+      </p:sp>
+      <p:sp>
+        <p:nvSpPr>
+          <p:cNvPr id="3" name="Notes Placeholder 2"/>
+          <p:cNvSpPr>
+            <a:spLocks noGrp="1"/>
+          </p:cNvSpPr>
+          <p:nvPr>
+            <p:ph type="body" idx="3" sz="quarter"/>
+          </p:nvPr>
+        </p:nvSpPr>
+        <p:spPr/>
+        <p:txBody>
+          <a:bodyPr/>
+          <a:lstStyle/>
+          <a:p>
+            <a:r>
+              <a:t>Slide ini menyatukan ketiganya dalam satu tabel: tiga paper di baris, empat dimensi SAFE di kolom. Terlihat jelas mana yang sudah terukur dan mana yang belum. Ini bagian jujurnya, penting kalau ada pertanyaan dari penguji. Dua dimensi, yaitu Explainable dan Accountable, masih lemah, belum punya alat ukur yang baku. Lalu untuk AutoML, yaitu AI yang merancang AI lain, kami tidak menemukan satu pun penelitian yang lolos pengecekan. Ini bukan karena malas mencari, tapi memang celah riset yang nyata. Mengakui keterbatasan ini justru membuat presentasi kita lebih kuat.</a:t>
+            </a:r>
+          </a:p>
+        </p:txBody>
+      </p:sp>
+      <p:sp>
+        <p:nvSpPr>
+          <p:cNvPr id="4" name="Slide Number Placeholder 3"/>
+          <p:cNvSpPr>
+            <a:spLocks noGrp="1"/>
+          </p:cNvSpPr>
+          <p:nvPr>
+            <p:ph type="sldNum" idx="5" sz="quarter"/>
+          </p:nvPr>
+        </p:nvSpPr>
+        <p:spPr/>
+      </p:sp>
+    </p:spTree>
+  </p:cSld>
+  <p:clrMapOvr>
+    <a:masterClrMapping/>
+  </p:clrMapOvr>
+</p:notes>
+</file>
+
+<file path=ppt/notesSlides/notesSlide15.xml><?xml version="1.0" encoding="utf-8"?>
+<p:notes xmlns:a="http://schemas.openxmlformats.org/drawingml/2006/main" xmlns:p="http://schemas.openxmlformats.org/presentationml/2006/main" xmlns:r="http://schemas.openxmlformats.org/officeDocument/2006/relationships">
+  <p:cSld>
+    <p:spTree>
+      <p:nvGrpSpPr>
+        <p:cNvPr id="1" name=""/>
+        <p:cNvGrpSpPr/>
+        <p:nvPr/>
+      </p:nvGrpSpPr>
+      <p:grpSpPr>
+        <a:xfrm>
+          <a:off x="0" y="0"/>
+          <a:ext cx="0" cy="0"/>
+          <a:chOff x="0" y="0"/>
+          <a:chExt cx="0" cy="0"/>
+        </a:xfrm>
+      </p:grpSpPr>
+      <p:sp>
+        <p:nvSpPr>
+          <p:cNvPr id="2" name="Slide Image Placeholder 1"/>
+          <p:cNvSpPr>
+            <a:spLocks noGrp="1"/>
+          </p:cNvSpPr>
+          <p:nvPr>
+            <p:ph type="sldImg" idx="2"/>
+          </p:nvPr>
+        </p:nvSpPr>
+        <p:spPr/>
+      </p:sp>
+      <p:sp>
+        <p:nvSpPr>
+          <p:cNvPr id="3" name="Notes Placeholder 2"/>
+          <p:cNvSpPr>
+            <a:spLocks noGrp="1"/>
+          </p:cNvSpPr>
+          <p:nvPr>
+            <p:ph type="body" idx="3" sz="quarter"/>
+          </p:nvPr>
+        </p:nvSpPr>
+        <p:spPr/>
+        <p:txBody>
+          <a:bodyPr/>
+          <a:lstStyle/>
+          <a:p>
+            <a:r>
+              <a:t>Tiga hal untuk dibawa pulang. Satu, alat ukur mengikuti jenis AI-nya, tidak ada satu ukuran untuk semua. Dua, ada alat ukur gabungan seperti DecodingTrust dan HELM yang menilai banyak aspek sekaligus. Tiga, selalu ada tarik-ulur, misalnya antara akurat dan adil, dan justru alat ukur yang baik membuat tarik-ulur itu terlihat sehingga bisa dikelola. Kalimat penutup: ketiga paper ini memberi alat yang bisa langsung dipakai untuk menguji apakah sebuah AI benar-benar SAFE.</a:t>
+            </a:r>
+          </a:p>
+        </p:txBody>
+      </p:sp>
+      <p:sp>
+        <p:nvSpPr>
+          <p:cNvPr id="4" name="Slide Number Placeholder 3"/>
+          <p:cNvSpPr>
+            <a:spLocks noGrp="1"/>
+          </p:cNvSpPr>
+          <p:nvPr>
+            <p:ph type="sldNum" idx="5" sz="quarter"/>
+          </p:nvPr>
+        </p:nvSpPr>
+        <p:spPr/>
+      </p:sp>
+    </p:spTree>
+  </p:cSld>
+  <p:clrMapOvr>
+    <a:masterClrMapping/>
+  </p:clrMapOvr>
+</p:notes>
+</file>
+
+<file path=ppt/notesSlides/notesSlide16.xml><?xml version="1.0" encoding="utf-8"?>
+<p:notes xmlns:a="http://schemas.openxmlformats.org/drawingml/2006/main" xmlns:p="http://schemas.openxmlformats.org/presentationml/2006/main" xmlns:r="http://schemas.openxmlformats.org/officeDocument/2006/relationships">
+  <p:cSld>
+    <p:spTree>
+      <p:nvGrpSpPr>
+        <p:cNvPr id="1" name=""/>
+        <p:cNvGrpSpPr/>
+        <p:nvPr/>
+      </p:nvGrpSpPr>
+      <p:grpSpPr>
+        <a:xfrm>
+          <a:off x="0" y="0"/>
+          <a:ext cx="0" cy="0"/>
+          <a:chOff x="0" y="0"/>
+          <a:chExt cx="0" cy="0"/>
+        </a:xfrm>
+      </p:grpSpPr>
+      <p:sp>
+        <p:nvSpPr>
+          <p:cNvPr id="2" name="Slide Image Placeholder 1"/>
+          <p:cNvSpPr>
+            <a:spLocks noGrp="1"/>
+          </p:cNvSpPr>
+          <p:nvPr>
+            <p:ph type="sldImg" idx="2"/>
+          </p:nvPr>
+        </p:nvSpPr>
+        <p:spPr/>
+      </p:sp>
+      <p:sp>
+        <p:nvSpPr>
+          <p:cNvPr id="3" name="Notes Placeholder 2"/>
+          <p:cNvSpPr>
+            <a:spLocks noGrp="1"/>
+          </p:cNvSpPr>
+          <p:nvPr>
+            <p:ph type="body" idx="3" sz="quarter"/>
+          </p:nvPr>
+        </p:nvSpPr>
+        <p:spPr/>
+        <p:txBody>
+          <a:bodyPr/>
+          <a:lstStyle/>
+          <a:p>
+            <a:r>
+              <a:t>Ini ketiga sumbernya, semua bisa diakses gratis di arXiv. Paper satu SoFCLR untuk keadilan, paper dua DecodingTrust untuk kepercayaan model bahasa, dan paper tiga HELM untuk perbandingan menyeluruh. Terima kasih, saya siap menerima pertanyaan.</a:t>
+            </a:r>
+          </a:p>
+        </p:txBody>
+      </p:sp>
+      <p:sp>
+        <p:nvSpPr>
+          <p:cNvPr id="4" name="Slide Number Placeholder 3"/>
+          <p:cNvSpPr>
+            <a:spLocks noGrp="1"/>
+          </p:cNvSpPr>
+          <p:nvPr>
+            <p:ph type="sldNum" idx="5" sz="quarter"/>
+          </p:nvPr>
+        </p:nvSpPr>
+        <p:spPr/>
+      </p:sp>
+    </p:spTree>
+  </p:cSld>
+  <p:clrMapOvr>
+    <a:masterClrMapping/>
+  </p:clrMapOvr>
+</p:notes>
+</file>
+
+<file path=ppt/notesSlides/notesSlide2.xml><?xml version="1.0" encoding="utf-8"?>
+<p:notes xmlns:a="http://schemas.openxmlformats.org/drawingml/2006/main" xmlns:p="http://schemas.openxmlformats.org/presentationml/2006/main" xmlns:r="http://schemas.openxmlformats.org/officeDocument/2006/relationships">
+  <p:cSld>
+    <p:spTree>
+      <p:nvGrpSpPr>
+        <p:cNvPr id="1" name=""/>
+        <p:cNvGrpSpPr/>
+        <p:nvPr/>
+      </p:nvGrpSpPr>
+      <p:grpSpPr>
+        <a:xfrm>
+          <a:off x="0" y="0"/>
+          <a:ext cx="0" cy="0"/>
+          <a:chOff x="0" y="0"/>
+          <a:chExt cx="0" cy="0"/>
+        </a:xfrm>
+      </p:grpSpPr>
+      <p:sp>
+        <p:nvSpPr>
+          <p:cNvPr id="2" name="Slide Image Placeholder 1"/>
+          <p:cNvSpPr>
+            <a:spLocks noGrp="1"/>
+          </p:cNvSpPr>
+          <p:nvPr>
+            <p:ph type="sldImg" idx="2"/>
+          </p:nvPr>
+        </p:nvSpPr>
+        <p:spPr/>
+      </p:sp>
+      <p:sp>
+        <p:nvSpPr>
+          <p:cNvPr id="3" name="Notes Placeholder 2"/>
+          <p:cNvSpPr>
+            <a:spLocks noGrp="1"/>
+          </p:cNvSpPr>
+          <p:nvPr>
+            <p:ph type="body" idx="3" sz="quarter"/>
+          </p:nvPr>
+        </p:nvSpPr>
+        <p:spPr/>
+        <p:txBody>
+          <a:bodyPr/>
+          <a:lstStyle/>
+          <a:p>
+            <a:r>
+              <a:t>Mari mulai dari dasar. Kenapa AI perlu diukur? Bayangkan AI seperti mobil baru. Sebelum dijual, mobil harus lolos uji rem, uji emisi, dan uji tabrak. SAFE AI itu kira-kira seperti uji kelayakan untuk AI. Empat hal yang diuji: Secure, apakah AI tahan dari serangan atau penipuan. Accountable, apakah ada yang bertanggung jawab dan ada catatan jejaknya. Fair, apakah AI tidak berat sebelah pada kelompok tertentu, misalnya gender atau ras. Dan Explainable, apakah keputusan AI bisa dijelaskan. Masalahnya, kalau perusahaan bilang 'AI kami aman dan adil', itu cuma omongan sampai bisa dibuktikan dengan angka. Mengubah klaim menjadi angka itulah inti dari tiga paper berikut.</a:t>
+            </a:r>
+          </a:p>
+        </p:txBody>
+      </p:sp>
+      <p:sp>
+        <p:nvSpPr>
+          <p:cNvPr id="4" name="Slide Number Placeholder 3"/>
+          <p:cNvSpPr>
+            <a:spLocks noGrp="1"/>
+          </p:cNvSpPr>
+          <p:nvPr>
+            <p:ph type="sldNum" idx="5" sz="quarter"/>
+          </p:nvPr>
+        </p:nvSpPr>
+        <p:spPr/>
+      </p:sp>
+    </p:spTree>
+  </p:cSld>
+  <p:clrMapOvr>
+    <a:masterClrMapping/>
+  </p:clrMapOvr>
+</p:notes>
+</file>
+
+<file path=ppt/notesSlides/notesSlide3.xml><?xml version="1.0" encoding="utf-8"?>
+<p:notes xmlns:a="http://schemas.openxmlformats.org/drawingml/2006/main" xmlns:p="http://schemas.openxmlformats.org/presentationml/2006/main" xmlns:r="http://schemas.openxmlformats.org/officeDocument/2006/relationships">
+  <p:cSld>
+    <p:spTree>
+      <p:nvGrpSpPr>
+        <p:cNvPr id="1" name=""/>
+        <p:cNvGrpSpPr/>
+        <p:nvPr/>
+      </p:nvGrpSpPr>
+      <p:grpSpPr>
+        <a:xfrm>
+          <a:off x="0" y="0"/>
+          <a:ext cx="0" cy="0"/>
+          <a:chOff x="0" y="0"/>
+          <a:chExt cx="0" cy="0"/>
+        </a:xfrm>
+      </p:grpSpPr>
+      <p:sp>
+        <p:nvSpPr>
+          <p:cNvPr id="2" name="Slide Image Placeholder 1"/>
+          <p:cNvSpPr>
+            <a:spLocks noGrp="1"/>
+          </p:cNvSpPr>
+          <p:nvPr>
+            <p:ph type="sldImg" idx="2"/>
+          </p:nvPr>
+        </p:nvSpPr>
+        <p:spPr/>
+      </p:sp>
+      <p:sp>
+        <p:nvSpPr>
+          <p:cNvPr id="3" name="Notes Placeholder 2"/>
+          <p:cNvSpPr>
+            <a:spLocks noGrp="1"/>
+          </p:cNvSpPr>
+          <p:nvPr>
+            <p:ph type="body" idx="3" sz="quarter"/>
+          </p:nvPr>
+        </p:nvSpPr>
+        <p:spPr/>
+        <p:txBody>
+          <a:bodyPr/>
+          <a:lstStyle/>
+          <a:p>
+            <a:r>
+              <a:t>Sebelum masuk detail, ini gambaran besarnya supaya kita tidak tersesat. Ketiga paper menjawab pertanyaan yang sama, tapi di tahap berbeda, seperti membangun rumah. Paper pertama, SoFCLR, fokus di tahap MEMBANGUN: bagaimana membuat AI adil sejak awal dilatih. Paper kedua, DecodingTrust, fokus di tahap MENGUJI secara keras: mereka sengaja menyerang AI untuk mencari titik lemahnya. Paper ketiga, HELM, fokus di tahap MEMBANDINGKAN: membuat semacam rapor standar untuk banyak AI sekaligus. Jadi alurnya bangun, uji, lalu bandingkan. Tiga paper ini saling melengkapi, bukan berdiri sendiri-sendiri.</a:t>
+            </a:r>
+          </a:p>
+        </p:txBody>
+      </p:sp>
+      <p:sp>
+        <p:nvSpPr>
+          <p:cNvPr id="4" name="Slide Number Placeholder 3"/>
+          <p:cNvSpPr>
+            <a:spLocks noGrp="1"/>
+          </p:cNvSpPr>
+          <p:nvPr>
+            <p:ph type="sldNum" idx="5" sz="quarter"/>
+          </p:nvPr>
+        </p:nvSpPr>
+        <p:spPr/>
+      </p:sp>
+    </p:spTree>
+  </p:cSld>
+  <p:clrMapOvr>
+    <a:masterClrMapping/>
+  </p:clrMapOvr>
+</p:notes>
+</file>
+
+<file path=ppt/notesSlides/notesSlide4.xml><?xml version="1.0" encoding="utf-8"?>
+<p:notes xmlns:a="http://schemas.openxmlformats.org/drawingml/2006/main" xmlns:p="http://schemas.openxmlformats.org/presentationml/2006/main" xmlns:r="http://schemas.openxmlformats.org/officeDocument/2006/relationships">
+  <p:cSld>
+    <p:spTree>
+      <p:nvGrpSpPr>
+        <p:cNvPr id="1" name=""/>
+        <p:cNvGrpSpPr/>
+        <p:nvPr/>
+      </p:nvGrpSpPr>
+      <p:grpSpPr>
+        <a:xfrm>
+          <a:off x="0" y="0"/>
+          <a:ext cx="0" cy="0"/>
+          <a:chOff x="0" y="0"/>
+          <a:chExt cx="0" cy="0"/>
+        </a:xfrm>
+      </p:grpSpPr>
+      <p:sp>
+        <p:nvSpPr>
+          <p:cNvPr id="2" name="Slide Image Placeholder 1"/>
+          <p:cNvSpPr>
+            <a:spLocks noGrp="1"/>
+          </p:cNvSpPr>
+          <p:nvPr>
+            <p:ph type="sldImg" idx="2"/>
+          </p:nvPr>
+        </p:nvSpPr>
+        <p:spPr/>
+      </p:sp>
+      <p:sp>
+        <p:nvSpPr>
+          <p:cNvPr id="3" name="Notes Placeholder 2"/>
+          <p:cNvSpPr>
+            <a:spLocks noGrp="1"/>
+          </p:cNvSpPr>
+          <p:nvPr>
+            <p:ph type="body" idx="3" sz="quarter"/>
+          </p:nvPr>
+        </p:nvSpPr>
+        <p:spPr/>
+        <p:txBody>
+          <a:bodyPr/>
+          <a:lstStyle/>
+          <a:p>
+            <a:r>
+              <a:t>Ini perkenalan singkat ketiga paper. Paper satu, SoFCLR, tahun 2024, membahas keadilan pada jenis AI yang belajar sendiri tanpa diberi contoh jawaban oleh manusia. Paper dua, DecodingTrust, memenangkan penghargaan di konferensi NeurIPS 2023, menguji model sekelas ChatGPT pada delapan aspek kepercayaan. Paper tiga, HELM, dari jurnal TMLR 2023, mengukur tiga puluh model bahasa sekaligus dengan tujuh ukuran. Berikutnya saya bahas satu per satu.</a:t>
+            </a:r>
+          </a:p>
+        </p:txBody>
+      </p:sp>
+      <p:sp>
+        <p:nvSpPr>
+          <p:cNvPr id="4" name="Slide Number Placeholder 3"/>
+          <p:cNvSpPr>
+            <a:spLocks noGrp="1"/>
+          </p:cNvSpPr>
+          <p:nvPr>
+            <p:ph type="sldNum" idx="5" sz="quarter"/>
+          </p:nvPr>
+        </p:nvSpPr>
+        <p:spPr/>
+      </p:sp>
+    </p:spTree>
+  </p:cSld>
+  <p:clrMapOvr>
+    <a:masterClrMapping/>
+  </p:clrMapOvr>
+</p:notes>
+</file>
+
+<file path=ppt/notesSlides/notesSlide5.xml><?xml version="1.0" encoding="utf-8"?>
+<p:notes xmlns:a="http://schemas.openxmlformats.org/drawingml/2006/main" xmlns:p="http://schemas.openxmlformats.org/presentationml/2006/main" xmlns:r="http://schemas.openxmlformats.org/officeDocument/2006/relationships">
+  <p:cSld>
+    <p:spTree>
+      <p:nvGrpSpPr>
+        <p:cNvPr id="1" name=""/>
+        <p:cNvGrpSpPr/>
+        <p:nvPr/>
+      </p:nvGrpSpPr>
+      <p:grpSpPr>
+        <a:xfrm>
+          <a:off x="0" y="0"/>
+          <a:ext cx="0" cy="0"/>
+          <a:chOff x="0" y="0"/>
+          <a:chExt cx="0" cy="0"/>
+        </a:xfrm>
+      </p:grpSpPr>
+      <p:sp>
+        <p:nvSpPr>
+          <p:cNvPr id="2" name="Slide Image Placeholder 1"/>
+          <p:cNvSpPr>
+            <a:spLocks noGrp="1"/>
+          </p:cNvSpPr>
+          <p:nvPr>
+            <p:ph type="sldImg" idx="2"/>
+          </p:nvPr>
+        </p:nvSpPr>
+        <p:spPr/>
+      </p:sp>
+      <p:sp>
+        <p:nvSpPr>
+          <p:cNvPr id="3" name="Notes Placeholder 2"/>
+          <p:cNvSpPr>
+            <a:spLocks noGrp="1"/>
+          </p:cNvSpPr>
+          <p:nvPr>
+            <p:ph type="body" idx="3" sz="quarter"/>
+          </p:nvPr>
+        </p:nvSpPr>
+        <p:spPr/>
+        <p:txBody>
+          <a:bodyPr/>
+          <a:lstStyle/>
+          <a:p>
+            <a:r>
+              <a:t>Kita mulai paper pertama, sedikit latar belakang dulu. Ada jenis AI yang belajar sendiri dari jutaan data tanpa label, tanpa kunci jawaban dari manusia. Istilahnya self-supervised learning. Contohnya AI yang belajar dari foto-foto di internet. Masalahnya, kalau datanya mengandung prasangka, AI ikut menyerap prasangka itu diam-diam. Mirip anak yang belajar dari internet tanpa pengawasan, bisa menyerap bias tanpa sadar. Yang lebih sulit, karena tidak ada label, kita susah mengukur seberapa adil AI ini. Paper SoFCLR menyelesaikan dua hal sekaligus: membuat AI lebih adil, dan tetap bisa mengukurnya.</a:t>
+            </a:r>
+          </a:p>
+        </p:txBody>
+      </p:sp>
+      <p:sp>
+        <p:nvSpPr>
+          <p:cNvPr id="4" name="Slide Number Placeholder 3"/>
+          <p:cNvSpPr>
+            <a:spLocks noGrp="1"/>
+          </p:cNvSpPr>
+          <p:nvPr>
+            <p:ph type="sldNum" idx="5" sz="quarter"/>
+          </p:nvPr>
+        </p:nvSpPr>
+        <p:spPr/>
+      </p:sp>
+    </p:spTree>
+  </p:cSld>
+  <p:clrMapOvr>
+    <a:masterClrMapping/>
+  </p:clrMapOvr>
+</p:notes>
+</file>
+
+<file path=ppt/notesSlides/notesSlide6.xml><?xml version="1.0" encoding="utf-8"?>
+<p:notes xmlns:a="http://schemas.openxmlformats.org/drawingml/2006/main" xmlns:p="http://schemas.openxmlformats.org/presentationml/2006/main" xmlns:r="http://schemas.openxmlformats.org/officeDocument/2006/relationships">
+  <p:cSld>
+    <p:spTree>
+      <p:nvGrpSpPr>
+        <p:cNvPr id="1" name=""/>
+        <p:cNvGrpSpPr/>
+        <p:nvPr/>
+      </p:nvGrpSpPr>
+      <p:grpSpPr>
+        <a:xfrm>
+          <a:off x="0" y="0"/>
+          <a:ext cx="0" cy="0"/>
+          <a:chOff x="0" y="0"/>
+          <a:chExt cx="0" cy="0"/>
+        </a:xfrm>
+      </p:grpSpPr>
+      <p:sp>
+        <p:nvSpPr>
+          <p:cNvPr id="2" name="Slide Image Placeholder 1"/>
+          <p:cNvSpPr>
+            <a:spLocks noGrp="1"/>
+          </p:cNvSpPr>
+          <p:nvPr>
+            <p:ph type="sldImg" idx="2"/>
+          </p:nvPr>
+        </p:nvSpPr>
+        <p:spPr/>
+      </p:sp>
+      <p:sp>
+        <p:nvSpPr>
+          <p:cNvPr id="3" name="Notes Placeholder 2"/>
+          <p:cNvSpPr>
+            <a:spLocks noGrp="1"/>
+          </p:cNvSpPr>
+          <p:nvPr>
+            <p:ph type="body" idx="3" sz="quarter"/>
+          </p:nvPr>
+        </p:nvSpPr>
+        <p:spPr/>
+        <p:txBody>
+          <a:bodyPr/>
+          <a:lstStyle/>
+          <a:p>
+            <a:r>
+              <a:t>Slide ini menunjukkan cara kerjanya. Jangan takut dengan rumusnya, intinya sederhana. Ada dua pemain yang saling tarik-menarik, seperti permainan kucing dan tikus. Pemain pertama bertugas membuat ringkasan data yang bagus, tapi sekaligus menyembunyikan informasi sensitif seperti gender. Pemain kedua, namanya discriminator, bertugas menebak gender dari ringkasan tadi. Kalau si penebak gagal, artinya informasi sensitif berhasil disembunyikan, dan itu tanda AI jadi lebih adil. Huruf alfa di rumus ibarat kenop pengatur: mau lebih mengutamakan keadilan, atau lebih mengutamakan ketepatan. Jadi rumus ini hanya cara matematis menuliskan permainan tarik-menarik tadi.</a:t>
+            </a:r>
+          </a:p>
+        </p:txBody>
+      </p:sp>
+      <p:sp>
+        <p:nvSpPr>
+          <p:cNvPr id="4" name="Slide Number Placeholder 3"/>
+          <p:cNvSpPr>
+            <a:spLocks noGrp="1"/>
+          </p:cNvSpPr>
+          <p:nvPr>
+            <p:ph type="sldNum" idx="5" sz="quarter"/>
+          </p:nvPr>
+        </p:nvSpPr>
+        <p:spPr/>
+      </p:sp>
+    </p:spTree>
+  </p:cSld>
+  <p:clrMapOvr>
+    <a:masterClrMapping/>
+  </p:clrMapOvr>
+</p:notes>
+</file>
+
+<file path=ppt/notesSlides/notesSlide7.xml><?xml version="1.0" encoding="utf-8"?>
+<p:notes xmlns:a="http://schemas.openxmlformats.org/drawingml/2006/main" xmlns:p="http://schemas.openxmlformats.org/presentationml/2006/main" xmlns:r="http://schemas.openxmlformats.org/officeDocument/2006/relationships">
+  <p:cSld>
+    <p:spTree>
+      <p:nvGrpSpPr>
+        <p:cNvPr id="1" name=""/>
+        <p:cNvGrpSpPr/>
+        <p:nvPr/>
+      </p:nvGrpSpPr>
+      <p:grpSpPr>
+        <a:xfrm>
+          <a:off x="0" y="0"/>
+          <a:ext cx="0" cy="0"/>
+          <a:chOff x="0" y="0"/>
+          <a:chExt cx="0" cy="0"/>
+        </a:xfrm>
+      </p:grpSpPr>
+      <p:sp>
+        <p:nvSpPr>
+          <p:cNvPr id="2" name="Slide Image Placeholder 1"/>
+          <p:cNvSpPr>
+            <a:spLocks noGrp="1"/>
+          </p:cNvSpPr>
+          <p:nvPr>
+            <p:ph type="sldImg" idx="2"/>
+          </p:nvPr>
+        </p:nvSpPr>
+        <p:spPr/>
+      </p:sp>
+      <p:sp>
+        <p:nvSpPr>
+          <p:cNvPr id="3" name="Notes Placeholder 2"/>
+          <p:cNvSpPr>
+            <a:spLocks noGrp="1"/>
+          </p:cNvSpPr>
+          <p:nvPr>
+            <p:ph type="body" idx="3" sz="quarter"/>
+          </p:nvPr>
+        </p:nvSpPr>
+        <p:spPr/>
+        <p:txBody>
+          <a:bodyPr/>
+          <a:lstStyle/>
+          <a:p>
+            <a:r>
+              <a:t>Bagaimana proses latihannya berjalan? Lima langkah di kiri ini diulang ribuan kali. Singkatnya: ambil sedikit data, perbaiki sedikit, ulangi. Yang menarik ada di kotak kanan. Biasanya jenis AI ini butuh komputer sangat besar untuk dilatih. Temuan paper ini adalah trik 'mencicil rata-rata', sehingga tidak perlu komputer raksasa. Di kotak bawah, mereka membuktikan secara matematis bahwa metode ini pasti sampai ke hasil yang baik, jadi bukan sekadar coba-coba. Untuk audiens umum, cukup ingat: metode ini lebih hemat dan terbukti.</a:t>
+            </a:r>
+          </a:p>
+        </p:txBody>
+      </p:sp>
+      <p:sp>
+        <p:nvSpPr>
+          <p:cNvPr id="4" name="Slide Number Placeholder 3"/>
+          <p:cNvSpPr>
+            <a:spLocks noGrp="1"/>
+          </p:cNvSpPr>
+          <p:nvPr>
+            <p:ph type="sldNum" idx="5" sz="quarter"/>
+          </p:nvPr>
+        </p:nvSpPr>
+        <p:spPr/>
+      </p:sp>
+    </p:spTree>
+  </p:cSld>
+  <p:clrMapOvr>
+    <a:masterClrMapping/>
+  </p:clrMapOvr>
+</p:notes>
+</file>
+
+<file path=ppt/notesSlides/notesSlide8.xml><?xml version="1.0" encoding="utf-8"?>
+<p:notes xmlns:a="http://schemas.openxmlformats.org/drawingml/2006/main" xmlns:p="http://schemas.openxmlformats.org/presentationml/2006/main" xmlns:r="http://schemas.openxmlformats.org/officeDocument/2006/relationships">
+  <p:cSld>
+    <p:spTree>
+      <p:nvGrpSpPr>
+        <p:cNvPr id="1" name=""/>
+        <p:cNvGrpSpPr/>
+        <p:nvPr/>
+      </p:nvGrpSpPr>
+      <p:grpSpPr>
+        <a:xfrm>
+          <a:off x="0" y="0"/>
+          <a:ext cx="0" cy="0"/>
+          <a:chOff x="0" y="0"/>
+          <a:chExt cx="0" cy="0"/>
+        </a:xfrm>
+      </p:grpSpPr>
+      <p:sp>
+        <p:nvSpPr>
+          <p:cNvPr id="2" name="Slide Image Placeholder 1"/>
+          <p:cNvSpPr>
+            <a:spLocks noGrp="1"/>
+          </p:cNvSpPr>
+          <p:nvPr>
+            <p:ph type="sldImg" idx="2"/>
+          </p:nvPr>
+        </p:nvSpPr>
+        <p:spPr/>
+      </p:sp>
+      <p:sp>
+        <p:nvSpPr>
+          <p:cNvPr id="3" name="Notes Placeholder 2"/>
+          <p:cNvSpPr>
+            <a:spLocks noGrp="1"/>
+          </p:cNvSpPr>
+          <p:nvPr>
+            <p:ph type="body" idx="3" sz="quarter"/>
+          </p:nvPr>
+        </p:nvSpPr>
+        <p:spPr/>
+        <p:txBody>
+          <a:bodyPr/>
+          <a:lstStyle/>
+          <a:p>
+            <a:r>
+              <a:t>Kenapa keadilan pada AI jenis ini sulit dicapai? Tiga alasan. Pertama, tidak ada label, jadi cara mengukur keadilan yang biasa tidak bisa langsung dipakai. Kedua, perhitungannya rumit karena harus membandingkan setiap data dengan seluruh data lain. Ketiga, dan ini penting, penulis menegaskan AI tidak otomatis adil dengan sendirinya. Kalau tidak sengaja diarahkan untuk adil, ia tetap menyerap bias dari data. Pesan moralnya: keadilan harus dirancang, bukan diharapkan muncul sendiri.</a:t>
+            </a:r>
+          </a:p>
+        </p:txBody>
+      </p:sp>
+      <p:sp>
+        <p:nvSpPr>
+          <p:cNvPr id="4" name="Slide Number Placeholder 3"/>
+          <p:cNvSpPr>
+            <a:spLocks noGrp="1"/>
+          </p:cNvSpPr>
+          <p:nvPr>
+            <p:ph type="sldNum" idx="5" sz="quarter"/>
+          </p:nvPr>
+        </p:nvSpPr>
+        <p:spPr/>
+      </p:sp>
+    </p:spTree>
+  </p:cSld>
+  <p:clrMapOvr>
+    <a:masterClrMapping/>
+  </p:clrMapOvr>
+</p:notes>
+</file>
+
+<file path=ppt/notesSlides/notesSlide9.xml><?xml version="1.0" encoding="utf-8"?>
+<p:notes xmlns:a="http://schemas.openxmlformats.org/drawingml/2006/main" xmlns:p="http://schemas.openxmlformats.org/presentationml/2006/main" xmlns:r="http://schemas.openxmlformats.org/officeDocument/2006/relationships">
+  <p:cSld>
+    <p:spTree>
+      <p:nvGrpSpPr>
+        <p:cNvPr id="1" name=""/>
+        <p:cNvGrpSpPr/>
+        <p:nvPr/>
+      </p:nvGrpSpPr>
+      <p:grpSpPr>
+        <a:xfrm>
+          <a:off x="0" y="0"/>
+          <a:ext cx="0" cy="0"/>
+          <a:chOff x="0" y="0"/>
+          <a:chExt cx="0" cy="0"/>
+        </a:xfrm>
+      </p:grpSpPr>
+      <p:sp>
+        <p:nvSpPr>
+          <p:cNvPr id="2" name="Slide Image Placeholder 1"/>
+          <p:cNvSpPr>
+            <a:spLocks noGrp="1"/>
+          </p:cNvSpPr>
+          <p:nvPr>
+            <p:ph type="sldImg" idx="2"/>
+          </p:nvPr>
+        </p:nvSpPr>
+        <p:spPr/>
+      </p:sp>
+      <p:sp>
+        <p:nvSpPr>
+          <p:cNvPr id="3" name="Notes Placeholder 2"/>
+          <p:cNvSpPr>
+            <a:spLocks noGrp="1"/>
+          </p:cNvSpPr>
+          <p:nvPr>
+            <p:ph type="body" idx="3" sz="quarter"/>
+          </p:nvPr>
+        </p:nvSpPr>
+        <p:spPr/>
+        <p:txBody>
+          <a:bodyPr/>
+          <a:lstStyle/>
+          <a:p>
+            <a:r>
+              <a:t>Ini rangkuman paper pertama dalam empat kotak. Metode: permainan tarik-menarik tadi. Kontribusi: ini metode pertama yang adil sekaligus terbukti dan hemat. Hasil: diuji pada dua kumpulan foto wajah bernama CelebA dan UTKFace. Angka yang turun di sini justru bagus, artinya ketimpangan berkurang alias makin adil, dan ketepatannya tetap terjaga sekitar delapan puluh lima persen. Future research, atau rencana lanjutan: penulis ingin memperluas ke data jenis lain seperti suara dan video. Yang perlu diingat: lebih adil, tanpa mengorbankan ketepatan.</a:t>
+            </a:r>
+          </a:p>
+        </p:txBody>
+      </p:sp>
+      <p:sp>
+        <p:nvSpPr>
+          <p:cNvPr id="4" name="Slide Number Placeholder 3"/>
+          <p:cNvSpPr>
+            <a:spLocks noGrp="1"/>
+          </p:cNvSpPr>
+          <p:nvPr>
+            <p:ph type="sldNum" idx="5" sz="quarter"/>
+          </p:nvPr>
+        </p:nvSpPr>
+        <p:spPr/>
+      </p:sp>
+    </p:spTree>
+  </p:cSld>
+  <p:clrMapOvr>
+    <a:masterClrMapping/>
+  </p:clrMapOvr>
+</p:notes>
 </file>
 
 <file path=ppt/slideLayouts/slideLayout1.xml><?xml version="1.0" encoding="utf-8"?>
@@ -10422,7 +11892,7 @@
                 </a:solidFill>
                 <a:latin typeface="Calibri"/>
               </a:rPr>
-              <a:t>Tiga Pelajaran</a:t>
+              <a:t>Poin Penutup</a:t>
             </a:r>
           </a:p>
         </p:txBody>
@@ -20041,4 +21511,324 @@
   </a:objectDefaults>
   <a:extraClrSchemeLst/>
 </a:theme>
+</file>
+
+<file path=ppt/theme/theme2.xml><?xml version="1.0" encoding="utf-8"?>
+<a:theme xmlns:a="http://schemas.openxmlformats.org/drawingml/2006/main" name="Office Theme">
+  <a:themeElements>
+    <a:clrScheme name="Office">
+      <a:dk1>
+        <a:sysClr val="windowText" lastClr="000000"/>
+      </a:dk1>
+      <a:lt1>
+        <a:sysClr val="window" lastClr="FFFFFF"/>
+      </a:lt1>
+      <a:dk2>
+        <a:srgbClr val="1F497D"/>
+      </a:dk2>
+      <a:lt2>
+        <a:srgbClr val="EEECE1"/>
+      </a:lt2>
+      <a:accent1>
+        <a:srgbClr val="4F81BD"/>
+      </a:accent1>
+      <a:accent2>
+        <a:srgbClr val="C0504D"/>
+      </a:accent2>
+      <a:accent3>
+        <a:srgbClr val="9BBB59"/>
+      </a:accent3>
+      <a:accent4>
+        <a:srgbClr val="8064A2"/>
+      </a:accent4>
+      <a:accent5>
+        <a:srgbClr val="4BACC6"/>
+      </a:accent5>
+      <a:accent6>
+        <a:srgbClr val="F79646"/>
+      </a:accent6>
+      <a:hlink>
+        <a:srgbClr val="0000FF"/>
+      </a:hlink>
+      <a:folHlink>
+        <a:srgbClr val="800080"/>
+      </a:folHlink>
+    </a:clrScheme>
+    <a:fontScheme name="Office">
+      <a:majorFont>
+        <a:latin typeface="Calibri"/>
+        <a:ea typeface=""/>
+        <a:cs typeface=""/>
+        <a:font script="Jpan" typeface="ＭＳ Ｐゴシック"/>
+        <a:font script="Hang" typeface="맑은 고딕"/>
+        <a:font script="Hans" typeface="宋体"/>
+        <a:font script="Hant" typeface="新細明體"/>
+        <a:font script="Arab" typeface="Times New Roman"/>
+        <a:font script="Hebr" typeface="Times New Roman"/>
+        <a:font script="Thai" typeface="Angsana New"/>
+        <a:font script="Ethi" typeface="Nyala"/>
+        <a:font script="Beng" typeface="Vrinda"/>
+        <a:font script="Gujr" typeface="Shruti"/>
+        <a:font script="Khmr" typeface="MoolBoran"/>
+        <a:font script="Knda" typeface="Tunga"/>
+        <a:font script="Guru" typeface="Raavi"/>
+        <a:font script="Cans" typeface="Euphemia"/>
+        <a:font script="Cher" typeface="Plantagenet Cherokee"/>
+        <a:font script="Yiii" typeface="Microsoft Yi Baiti"/>
+        <a:font script="Tibt" typeface="Microsoft Himalaya"/>
+        <a:font script="Thaa" typeface="MV Boli"/>
+        <a:font script="Deva" typeface="Mangal"/>
+        <a:font script="Telu" typeface="Gautami"/>
+        <a:font script="Taml" typeface="Latha"/>
+        <a:font script="Syrc" typeface="Estrangelo Edessa"/>
+        <a:font script="Orya" typeface="Kalinga"/>
+        <a:font script="Mlym" typeface="Kartika"/>
+        <a:font script="Laoo" typeface="DokChampa"/>
+        <a:font script="Sinh" typeface="Iskoola Pota"/>
+        <a:font script="Mong" typeface="Mongolian Baiti"/>
+        <a:font script="Viet" typeface="Times New Roman"/>
+        <a:font script="Uigh" typeface="Microsoft Uighur"/>
+        <a:font script="Geor" typeface="Sylfaen"/>
+      </a:majorFont>
+      <a:minorFont>
+        <a:latin typeface="Calibri"/>
+        <a:ea typeface=""/>
+        <a:cs typeface=""/>
+        <a:font script="Jpan" typeface="ＭＳ Ｐゴシック"/>
+        <a:font script="Hang" typeface="맑은 고딕"/>
+        <a:font script="Hans" typeface="宋体"/>
+        <a:font script="Hant" typeface="新細明體"/>
+        <a:font script="Arab" typeface="Arial"/>
+        <a:font script="Hebr" typeface="Arial"/>
+        <a:font script="Thai" typeface="Cordia New"/>
+        <a:font script="Ethi" typeface="Nyala"/>
+        <a:font script="Beng" typeface="Vrinda"/>
+        <a:font script="Gujr" typeface="Shruti"/>
+        <a:font script="Khmr" typeface="DaunPenh"/>
+        <a:font script="Knda" typeface="Tunga"/>
+        <a:font script="Guru" typeface="Raavi"/>
+        <a:font script="Cans" typeface="Euphemia"/>
+        <a:font script="Cher" typeface="Plantagenet Cherokee"/>
+        <a:font script="Yiii" typeface="Microsoft Yi Baiti"/>
+        <a:font script="Tibt" typeface="Microsoft Himalaya"/>
+        <a:font script="Thaa" typeface="MV Boli"/>
+        <a:font script="Deva" typeface="Mangal"/>
+        <a:font script="Telu" typeface="Gautami"/>
+        <a:font script="Taml" typeface="Latha"/>
+        <a:font script="Syrc" typeface="Estrangelo Edessa"/>
+        <a:font script="Orya" typeface="Kalinga"/>
+        <a:font script="Mlym" typeface="Kartika"/>
+        <a:font script="Laoo" typeface="DokChampa"/>
+        <a:font script="Sinh" typeface="Iskoola Pota"/>
+        <a:font script="Mong" typeface="Mongolian Baiti"/>
+        <a:font script="Viet" typeface="Arial"/>
+        <a:font script="Uigh" typeface="Microsoft Uighur"/>
+        <a:font script="Geor" typeface="Sylfaen"/>
+      </a:minorFont>
+    </a:fontScheme>
+    <a:fmtScheme name="Office">
+      <a:fillStyleLst>
+        <a:solidFill>
+          <a:schemeClr val="phClr"/>
+        </a:solidFill>
+        <a:gradFill rotWithShape="1">
+          <a:gsLst>
+            <a:gs pos="0">
+              <a:schemeClr val="phClr">
+                <a:tint val="50000"/>
+                <a:satMod val="300000"/>
+              </a:schemeClr>
+            </a:gs>
+            <a:gs pos="35000">
+              <a:schemeClr val="phClr">
+                <a:tint val="37000"/>
+                <a:satMod val="300000"/>
+              </a:schemeClr>
+            </a:gs>
+            <a:gs pos="100000">
+              <a:schemeClr val="phClr">
+                <a:tint val="15000"/>
+                <a:satMod val="350000"/>
+              </a:schemeClr>
+            </a:gs>
+          </a:gsLst>
+          <a:lin ang="16200000" scaled="1"/>
+        </a:gradFill>
+        <a:gradFill rotWithShape="1">
+          <a:gsLst>
+            <a:gs pos="0">
+              <a:schemeClr val="phClr">
+                <a:tint val="100000"/>
+                <a:shade val="100000"/>
+                <a:satMod val="130000"/>
+              </a:schemeClr>
+            </a:gs>
+            <a:gs pos="100000">
+              <a:schemeClr val="phClr">
+                <a:tint val="50000"/>
+                <a:shade val="100000"/>
+                <a:satMod val="350000"/>
+              </a:schemeClr>
+            </a:gs>
+          </a:gsLst>
+          <a:lin ang="16200000" scaled="0"/>
+        </a:gradFill>
+      </a:fillStyleLst>
+      <a:lnStyleLst>
+        <a:ln w="9525" cap="flat" cmpd="sng" algn="ctr">
+          <a:solidFill>
+            <a:schemeClr val="phClr">
+              <a:shade val="95000"/>
+              <a:satMod val="105000"/>
+            </a:schemeClr>
+          </a:solidFill>
+          <a:prstDash val="solid"/>
+        </a:ln>
+        <a:ln w="25400" cap="flat" cmpd="sng" algn="ctr">
+          <a:solidFill>
+            <a:schemeClr val="phClr"/>
+          </a:solidFill>
+          <a:prstDash val="solid"/>
+        </a:ln>
+        <a:ln w="38100" cap="flat" cmpd="sng" algn="ctr">
+          <a:solidFill>
+            <a:schemeClr val="phClr"/>
+          </a:solidFill>
+          <a:prstDash val="solid"/>
+        </a:ln>
+      </a:lnStyleLst>
+      <a:effectStyleLst>
+        <a:effectStyle>
+          <a:effectLst>
+            <a:outerShdw blurRad="40000" dist="20000" dir="5400000" rotWithShape="0">
+              <a:srgbClr val="000000">
+                <a:alpha val="38000"/>
+              </a:srgbClr>
+            </a:outerShdw>
+          </a:effectLst>
+        </a:effectStyle>
+        <a:effectStyle>
+          <a:effectLst>
+            <a:outerShdw blurRad="40000" dist="23000" dir="5400000" rotWithShape="0">
+              <a:srgbClr val="000000">
+                <a:alpha val="35000"/>
+              </a:srgbClr>
+            </a:outerShdw>
+          </a:effectLst>
+        </a:effectStyle>
+        <a:effectStyle>
+          <a:effectLst>
+            <a:outerShdw blurRad="40000" dist="23000" dir="5400000" rotWithShape="0">
+              <a:srgbClr val="000000">
+                <a:alpha val="35000"/>
+              </a:srgbClr>
+            </a:outerShdw>
+          </a:effectLst>
+          <a:scene3d>
+            <a:camera prst="orthographicFront">
+              <a:rot lat="0" lon="0" rev="0"/>
+            </a:camera>
+            <a:lightRig rig="threePt" dir="t">
+              <a:rot lat="0" lon="0" rev="1200000"/>
+            </a:lightRig>
+          </a:scene3d>
+          <a:sp3d>
+            <a:bevelT w="63500" h="25400"/>
+          </a:sp3d>
+        </a:effectStyle>
+      </a:effectStyleLst>
+      <a:bgFillStyleLst>
+        <a:solidFill>
+          <a:schemeClr val="phClr"/>
+        </a:solidFill>
+        <a:gradFill rotWithShape="1">
+          <a:gsLst>
+            <a:gs pos="0">
+              <a:schemeClr val="phClr">
+                <a:tint val="40000"/>
+                <a:satMod val="350000"/>
+              </a:schemeClr>
+            </a:gs>
+            <a:gs pos="40000">
+              <a:schemeClr val="phClr">
+                <a:tint val="45000"/>
+                <a:shade val="99000"/>
+                <a:satMod val="350000"/>
+              </a:schemeClr>
+            </a:gs>
+            <a:gs pos="100000">
+              <a:schemeClr val="phClr">
+                <a:shade val="20000"/>
+                <a:satMod val="255000"/>
+              </a:schemeClr>
+            </a:gs>
+          </a:gsLst>
+          <a:path path="circle">
+            <a:fillToRect l="50000" t="-80000" r="50000" b="180000"/>
+          </a:path>
+        </a:gradFill>
+        <a:gradFill rotWithShape="1">
+          <a:gsLst>
+            <a:gs pos="0">
+              <a:schemeClr val="phClr">
+                <a:tint val="80000"/>
+                <a:satMod val="300000"/>
+              </a:schemeClr>
+            </a:gs>
+            <a:gs pos="100000">
+              <a:schemeClr val="phClr">
+                <a:shade val="30000"/>
+                <a:satMod val="200000"/>
+              </a:schemeClr>
+            </a:gs>
+          </a:gsLst>
+          <a:path path="circle">
+            <a:fillToRect l="50000" t="50000" r="50000" b="50000"/>
+          </a:path>
+        </a:gradFill>
+      </a:bgFillStyleLst>
+    </a:fmtScheme>
+  </a:themeElements>
+  <a:objectDefaults>
+    <a:spDef>
+      <a:spPr/>
+      <a:bodyPr/>
+      <a:lstStyle/>
+      <a:style>
+        <a:lnRef idx="1">
+          <a:schemeClr val="accent1"/>
+        </a:lnRef>
+        <a:fillRef idx="3">
+          <a:schemeClr val="accent1"/>
+        </a:fillRef>
+        <a:effectRef idx="2">
+          <a:schemeClr val="accent1"/>
+        </a:effectRef>
+        <a:fontRef idx="minor">
+          <a:schemeClr val="lt1"/>
+        </a:fontRef>
+      </a:style>
+    </a:spDef>
+    <a:lnDef>
+      <a:spPr/>
+      <a:bodyPr/>
+      <a:lstStyle/>
+      <a:style>
+        <a:lnRef idx="2">
+          <a:schemeClr val="accent1"/>
+        </a:lnRef>
+        <a:fillRef idx="0">
+          <a:schemeClr val="accent1"/>
+        </a:fillRef>
+        <a:effectRef idx="1">
+          <a:schemeClr val="accent1"/>
+        </a:effectRef>
+        <a:fontRef idx="minor">
+          <a:schemeClr val="tx1"/>
+        </a:fontRef>
+      </a:style>
+    </a:lnDef>
+  </a:objectDefaults>
+  <a:extraClrSchemeLst/>
+</a:theme>
 </file>
</xml_diff>

<commit_message>
Tambah strip analogi awam di slide 5, 6, 12
Helper analogi() + callout amber di bawah slide SoFCLR (anak belajar
tanpa pengawasan), Cara Kerja SoFCLR (kucing-tikus), dan HELM (rapor
sekolah) agar pembaca awam paham walau tanpa narasi lisan.

Co-Authored-By: Claude Opus 4.8 (1M context) <noreply@anthropic.com>
</commit_message>
<xml_diff>
--- a/safe/metrics/SAFE-AI-Metrics.pptx
+++ b/safe/metrics/SAFE-AI-Metrics.pptx
@@ -8676,6 +8676,103 @@
           </a:p>
         </p:txBody>
       </p:sp>
+      <p:sp>
+        <p:nvSpPr>
+          <p:cNvPr id="30" name="Rectangle 29"/>
+          <p:cNvSpPr/>
+          <p:nvPr/>
+        </p:nvSpPr>
+        <p:spPr>
+          <a:xfrm>
+            <a:off x="548640" y="6053328"/>
+            <a:ext cx="11091672" cy="640080"/>
+          </a:xfrm>
+          <a:prstGeom prst="rect">
+            <a:avLst/>
+          </a:prstGeom>
+          <a:solidFill>
+            <a:srgbClr val="1E293B"/>
+          </a:solidFill>
+          <a:ln w="15875">
+            <a:solidFill>
+              <a:srgbClr val="FBBF24"/>
+            </a:solidFill>
+          </a:ln>
+          <a:effectLst/>
+        </p:spPr>
+        <p:style>
+          <a:lnRef idx="1">
+            <a:schemeClr val="accent1"/>
+          </a:lnRef>
+          <a:fillRef idx="3">
+            <a:schemeClr val="accent1"/>
+          </a:fillRef>
+          <a:effectRef idx="2">
+            <a:schemeClr val="accent1"/>
+          </a:effectRef>
+          <a:fontRef idx="minor">
+            <a:schemeClr val="lt1"/>
+          </a:fontRef>
+        </p:style>
+        <p:txBody>
+          <a:bodyPr rtlCol="0" anchor="ctr"/>
+          <a:lstStyle/>
+          <a:p>
+            <a:pPr algn="ctr"/>
+          </a:p>
+        </p:txBody>
+      </p:sp>
+      <p:sp>
+        <p:nvSpPr>
+          <p:cNvPr id="31" name="TextBox 30"/>
+          <p:cNvSpPr txBox="1"/>
+          <p:nvPr/>
+        </p:nvSpPr>
+        <p:spPr>
+          <a:xfrm>
+            <a:off x="777240" y="6053328"/>
+            <a:ext cx="10607040" cy="640080"/>
+          </a:xfrm>
+          <a:prstGeom prst="rect">
+            <a:avLst/>
+          </a:prstGeom>
+          <a:noFill/>
+        </p:spPr>
+        <p:txBody>
+          <a:bodyPr wrap="square" anchor="ctr">
+            <a:spAutoFit/>
+          </a:bodyPr>
+          <a:lstStyle/>
+          <a:p>
+            <a:pPr algn="l">
+              <a:lnSpc>
+                <a:spcPct val="110000"/>
+              </a:lnSpc>
+              <a:spcAft>
+                <a:spcPts val="600"/>
+              </a:spcAft>
+            </a:pPr>
+            <a:r>
+              <a:rPr sz="1250" b="1">
+                <a:solidFill>
+                  <a:srgbClr val="FBBF24"/>
+                </a:solidFill>
+                <a:latin typeface="Calibri"/>
+              </a:rPr>
+              <a:t>Analogi:  </a:t>
+            </a:r>
+            <a:r>
+              <a:rPr sz="1250" b="0">
+                <a:solidFill>
+                  <a:srgbClr val="F1F5F9"/>
+                </a:solidFill>
+                <a:latin typeface="Calibri"/>
+              </a:rPr>
+              <a:t>seperti rapor sekolah dengan banyak mata pelajaran. HELM memberi nilai 7 ukuran untuk 30 model AI agar bisa dibandingkan secara adil.</a:t>
+            </a:r>
+          </a:p>
+        </p:txBody>
+      </p:sp>
     </p:spTree>
   </p:cSld>
   <p:clrMapOvr>
@@ -17942,6 +18039,103 @@
           </a:p>
         </p:txBody>
       </p:sp>
+      <p:sp>
+        <p:nvSpPr>
+          <p:cNvPr id="21" name="Rectangle 20"/>
+          <p:cNvSpPr/>
+          <p:nvPr/>
+        </p:nvSpPr>
+        <p:spPr>
+          <a:xfrm>
+            <a:off x="548640" y="5989320"/>
+            <a:ext cx="11091672" cy="640080"/>
+          </a:xfrm>
+          <a:prstGeom prst="rect">
+            <a:avLst/>
+          </a:prstGeom>
+          <a:solidFill>
+            <a:srgbClr val="1E293B"/>
+          </a:solidFill>
+          <a:ln w="15875">
+            <a:solidFill>
+              <a:srgbClr val="FBBF24"/>
+            </a:solidFill>
+          </a:ln>
+          <a:effectLst/>
+        </p:spPr>
+        <p:style>
+          <a:lnRef idx="1">
+            <a:schemeClr val="accent1"/>
+          </a:lnRef>
+          <a:fillRef idx="3">
+            <a:schemeClr val="accent1"/>
+          </a:fillRef>
+          <a:effectRef idx="2">
+            <a:schemeClr val="accent1"/>
+          </a:effectRef>
+          <a:fontRef idx="minor">
+            <a:schemeClr val="lt1"/>
+          </a:fontRef>
+        </p:style>
+        <p:txBody>
+          <a:bodyPr rtlCol="0" anchor="ctr"/>
+          <a:lstStyle/>
+          <a:p>
+            <a:pPr algn="ctr"/>
+          </a:p>
+        </p:txBody>
+      </p:sp>
+      <p:sp>
+        <p:nvSpPr>
+          <p:cNvPr id="22" name="TextBox 21"/>
+          <p:cNvSpPr txBox="1"/>
+          <p:nvPr/>
+        </p:nvSpPr>
+        <p:spPr>
+          <a:xfrm>
+            <a:off x="777240" y="5989320"/>
+            <a:ext cx="10607040" cy="640080"/>
+          </a:xfrm>
+          <a:prstGeom prst="rect">
+            <a:avLst/>
+          </a:prstGeom>
+          <a:noFill/>
+        </p:spPr>
+        <p:txBody>
+          <a:bodyPr wrap="square" anchor="ctr">
+            <a:spAutoFit/>
+          </a:bodyPr>
+          <a:lstStyle/>
+          <a:p>
+            <a:pPr algn="l">
+              <a:lnSpc>
+                <a:spcPct val="110000"/>
+              </a:lnSpc>
+              <a:spcAft>
+                <a:spcPts val="600"/>
+              </a:spcAft>
+            </a:pPr>
+            <a:r>
+              <a:rPr sz="1250" b="1">
+                <a:solidFill>
+                  <a:srgbClr val="FBBF24"/>
+                </a:solidFill>
+                <a:latin typeface="Calibri"/>
+              </a:rPr>
+              <a:t>Analogi:  </a:t>
+            </a:r>
+            <a:r>
+              <a:rPr sz="1250" b="0">
+                <a:solidFill>
+                  <a:srgbClr val="F1F5F9"/>
+                </a:solidFill>
+                <a:latin typeface="Calibri"/>
+              </a:rPr>
+              <a:t>seperti anak yang belajar dari internet tanpa pengawasan, AI bisa ikut menyerap prasangka dari data tanpa disuruh.</a:t>
+            </a:r>
+          </a:p>
+        </p:txBody>
+      </p:sp>
     </p:spTree>
   </p:cSld>
   <p:clrMapOvr>
@@ -18624,6 +18818,103 @@
                 <a:latin typeface="Calibri"/>
               </a:rPr>
               <a:t>, sehingga representasi tidak membawa informasi sensitif.</a:t>
+            </a:r>
+          </a:p>
+        </p:txBody>
+      </p:sp>
+      <p:sp>
+        <p:nvSpPr>
+          <p:cNvPr id="17" name="Rectangle 16"/>
+          <p:cNvSpPr/>
+          <p:nvPr/>
+        </p:nvSpPr>
+        <p:spPr>
+          <a:xfrm>
+            <a:off x="548640" y="6126480"/>
+            <a:ext cx="11091672" cy="640080"/>
+          </a:xfrm>
+          <a:prstGeom prst="rect">
+            <a:avLst/>
+          </a:prstGeom>
+          <a:solidFill>
+            <a:srgbClr val="1E293B"/>
+          </a:solidFill>
+          <a:ln w="15875">
+            <a:solidFill>
+              <a:srgbClr val="FBBF24"/>
+            </a:solidFill>
+          </a:ln>
+          <a:effectLst/>
+        </p:spPr>
+        <p:style>
+          <a:lnRef idx="1">
+            <a:schemeClr val="accent1"/>
+          </a:lnRef>
+          <a:fillRef idx="3">
+            <a:schemeClr val="accent1"/>
+          </a:fillRef>
+          <a:effectRef idx="2">
+            <a:schemeClr val="accent1"/>
+          </a:effectRef>
+          <a:fontRef idx="minor">
+            <a:schemeClr val="lt1"/>
+          </a:fontRef>
+        </p:style>
+        <p:txBody>
+          <a:bodyPr rtlCol="0" anchor="ctr"/>
+          <a:lstStyle/>
+          <a:p>
+            <a:pPr algn="ctr"/>
+          </a:p>
+        </p:txBody>
+      </p:sp>
+      <p:sp>
+        <p:nvSpPr>
+          <p:cNvPr id="18" name="TextBox 17"/>
+          <p:cNvSpPr txBox="1"/>
+          <p:nvPr/>
+        </p:nvSpPr>
+        <p:spPr>
+          <a:xfrm>
+            <a:off x="777240" y="6126480"/>
+            <a:ext cx="10607040" cy="640080"/>
+          </a:xfrm>
+          <a:prstGeom prst="rect">
+            <a:avLst/>
+          </a:prstGeom>
+          <a:noFill/>
+        </p:spPr>
+        <p:txBody>
+          <a:bodyPr wrap="square" anchor="ctr">
+            <a:spAutoFit/>
+          </a:bodyPr>
+          <a:lstStyle/>
+          <a:p>
+            <a:pPr algn="l">
+              <a:lnSpc>
+                <a:spcPct val="110000"/>
+              </a:lnSpc>
+              <a:spcAft>
+                <a:spcPts val="600"/>
+              </a:spcAft>
+            </a:pPr>
+            <a:r>
+              <a:rPr sz="1250" b="1">
+                <a:solidFill>
+                  <a:srgbClr val="FBBF24"/>
+                </a:solidFill>
+                <a:latin typeface="Calibri"/>
+              </a:rPr>
+              <a:t>Analogi:  </a:t>
+            </a:r>
+            <a:r>
+              <a:rPr sz="1250" b="0">
+                <a:solidFill>
+                  <a:srgbClr val="F1F5F9"/>
+                </a:solidFill>
+                <a:latin typeface="Calibri"/>
+              </a:rPr>
+              <a:t>permainan kucing-tikus. Satu pemain menyembunyikan info gender, satu mencoba menebaknya. Kalau penebak gagal, berarti AI makin adil.</a:t>
             </a:r>
           </a:p>
         </p:txBody>

</xml_diff>